<commit_message>
Remove em dashes from final presentation deck
</commit_message>
<xml_diff>
--- a/05-insights/Fable-Final-Presentation.pptx
+++ b/05-insights/Fable-Final-Presentation.pptx
@@ -3332,7 +3332,7 @@
                 </a:solidFill>
                 <a:latin typeface="Arial"/>
               </a:rPr>
-              <a:t>We retain users after their acute need is resolved — by building confidence, proactive action, and successful re-engagement.</a:t>
+              <a:t>We retain users after their acute need is resolved, by building confidence, proactive action, and successful re-engagement.</a:t>
             </a:r>
           </a:p>
         </p:txBody>
@@ -3681,7 +3681,7 @@
                 </a:solidFill>
                 <a:latin typeface="Arial"/>
               </a:rPr>
-              <a:t>•  Winning aspiration — </a:t>
+              <a:t>•  Winning aspiration, </a:t>
             </a:r>
             <a:r>
               <a:rPr sz="1250">
@@ -3706,7 +3706,7 @@
                 </a:solidFill>
                 <a:latin typeface="Arial"/>
               </a:rPr>
-              <a:t>•  Where to play — </a:t>
+              <a:t>•  Where to play, </a:t>
             </a:r>
             <a:r>
               <a:rPr sz="1250">
@@ -3731,7 +3731,7 @@
                 </a:solidFill>
                 <a:latin typeface="Arial"/>
               </a:rPr>
-              <a:t>•  How to win — </a:t>
+              <a:t>•  How to win, </a:t>
             </a:r>
             <a:r>
               <a:rPr sz="1250">
@@ -3756,7 +3756,7 @@
                 </a:solidFill>
                 <a:latin typeface="Arial"/>
               </a:rPr>
-              <a:t>•  Capabilities — </a:t>
+              <a:t>•  Capabilities, </a:t>
             </a:r>
             <a:r>
               <a:rPr sz="1250">
@@ -3889,7 +3889,7 @@
                 </a:solidFill>
                 <a:latin typeface="Georgia"/>
               </a:rPr>
-              <a:t>Fable will not optimize for engagement — even when doing so would accelerate growth.</a:t>
+              <a:t>Fable will not optimize for engagement, even when doing so would accelerate growth.</a:t>
             </a:r>
           </a:p>
         </p:txBody>
@@ -3928,7 +3928,7 @@
                 </a:solidFill>
                 <a:latin typeface="Arial"/>
               </a:rPr>
-              <a:t>Engagement mechanics create dependence. This strategy only works if users grow more resilient — including when they open Fable less.</a:t>
+              <a:t>Engagement mechanics create dependence. This strategy only works if users grow more resilient, including when they open Fable less.</a:t>
             </a:r>
           </a:p>
         </p:txBody>
@@ -4054,7 +4054,7 @@
                 </a:solidFill>
                 <a:latin typeface="Arial"/>
               </a:rPr>
-              <a:t>Objective: Enable users to sustain well-being after the acute phase — building confidence, self-awareness, and resilience without increasing dependence on Fable.</a:t>
+              <a:t>Objective: Enable users to sustain well-being after the acute phase, building confidence, self-awareness, and resilience without increasing dependence on Fable.</a:t>
             </a:r>
           </a:p>
         </p:txBody>
@@ -4471,7 +4471,7 @@
                 </a:solidFill>
                 <a:latin typeface="Arial"/>
               </a:rPr>
-              <a:t> — re-engagement, KR3 30% → 55% (PM2)</a:t>
+              <a:t>, re-engagement, KR3 30% → 55% (PM2)</a:t>
             </a:r>
           </a:p>
           <a:p>
@@ -4496,7 +4496,7 @@
                 </a:solidFill>
                 <a:latin typeface="Arial"/>
               </a:rPr>
-              <a:t> — confidence + proactive action, KR1/KR2 (PM3)</a:t>
+              <a:t>, confidence + proactive action, KR1/KR2 (PM3)</a:t>
             </a:r>
           </a:p>
           <a:p>
@@ -4521,7 +4521,7 @@
                 </a:solidFill>
                 <a:latin typeface="Arial"/>
               </a:rPr>
-              <a:t> — long-term return behavior, KR3 (PM2)</a:t>
+              <a:t>, long-term return behavior, KR3 (PM2)</a:t>
             </a:r>
           </a:p>
         </p:txBody>
@@ -4656,7 +4656,7 @@
                 </a:solidFill>
                 <a:latin typeface="Arial"/>
               </a:rPr>
-              <a:t> — long-term retention (PM2)</a:t>
+              <a:t>, long-term retention (PM2)</a:t>
             </a:r>
           </a:p>
           <a:p>
@@ -4681,7 +4681,7 @@
                 </a:solidFill>
                 <a:latin typeface="Arial"/>
               </a:rPr>
-              <a:t> — intervene before users are overwhelmed, KR2 (PM3)</a:t>
+              <a:t>, intervene before users are overwhelmed, KR2 (PM3)</a:t>
             </a:r>
           </a:p>
           <a:p>
@@ -4706,7 +4706,7 @@
                 </a:solidFill>
                 <a:latin typeface="Arial"/>
               </a:rPr>
-              <a:t> — re-engagement without dependency, KR3 (PM2)</a:t>
+              <a:t>, re-engagement without dependency, KR3 (PM2)</a:t>
             </a:r>
           </a:p>
         </p:txBody>
@@ -4841,7 +4841,7 @@
                 </a:solidFill>
                 <a:latin typeface="Arial"/>
               </a:rPr>
-              <a:t> — via partners, for needs beyond self-guided (PM3)</a:t>
+              <a:t>, via partners, for needs beyond self-guided (PM3)</a:t>
             </a:r>
           </a:p>
           <a:p>
@@ -4866,7 +4866,7 @@
                 </a:solidFill>
                 <a:latin typeface="Arial"/>
               </a:rPr>
-              <a:t> — earlier recognition of well-being changes (PM3)</a:t>
+              <a:t>, earlier recognition of well-being changes (PM3)</a:t>
             </a:r>
           </a:p>
           <a:p>
@@ -4891,7 +4891,7 @@
                 </a:solidFill>
                 <a:latin typeface="Arial"/>
               </a:rPr>
-              <a:t> — only once the retention model is proven in core markets (PM2)</a:t>
+              <a:t>, only once the retention model is proven in core markets (PM2)</a:t>
             </a:r>
           </a:p>
         </p:txBody>
@@ -5409,7 +5409,7 @@
                 </a:solidFill>
                 <a:latin typeface="Arial"/>
               </a:rPr>
-              <a:t> — roadmap and OKRs for KR1–KR3</a:t>
+              <a:t>, roadmap and OKRs for KR1–KR3</a:t>
             </a:r>
           </a:p>
           <a:p>
@@ -5434,7 +5434,7 @@
                 </a:solidFill>
                 <a:latin typeface="Arial"/>
               </a:rPr>
-              <a:t> — activation and the onboarding experience</a:t>
+              <a:t>, activation and the onboarding experience</a:t>
             </a:r>
           </a:p>
           <a:p>
@@ -5459,7 +5459,7 @@
                 </a:solidFill>
                 <a:latin typeface="Arial"/>
               </a:rPr>
-              <a:t> — re-engagement journeys and notification strategy</a:t>
+              <a:t>, re-engagement journeys and notification strategy</a:t>
             </a:r>
           </a:p>
           <a:p>
@@ -5484,7 +5484,7 @@
                 </a:solidFill>
                 <a:latin typeface="Arial"/>
               </a:rPr>
-              <a:t> — personalization engine and wellness memory</a:t>
+              <a:t>, personalization engine and wellness memory</a:t>
             </a:r>
           </a:p>
         </p:txBody>
@@ -5571,7 +5571,7 @@
                 </a:solidFill>
                 <a:latin typeface="Arial"/>
               </a:rPr>
-              <a:t>OUT OF SCOPE — BY DESIGN</a:t>
+              <a:t>OUT OF SCOPE, BY DESIGN</a:t>
             </a:r>
           </a:p>
         </p:txBody>
@@ -5619,7 +5619,7 @@
                 </a:solidFill>
                 <a:latin typeface="Arial"/>
               </a:rPr>
-              <a:t> — DAU, streaks, session frequency, pressure loops</a:t>
+              <a:t>, DAU, streaks, session frequency, pressure loops</a:t>
             </a:r>
           </a:p>
           <a:p>
@@ -5694,7 +5694,7 @@
                 </a:solidFill>
                 <a:latin typeface="Arial"/>
               </a:rPr>
-              <a:t> — web, wearables, integrations without KR evidence</a:t>
+              <a:t>, web, wearables, integrations without KR evidence</a:t>
             </a:r>
           </a:p>
         </p:txBody>
@@ -5827,7 +5827,7 @@
                 </a:solidFill>
                 <a:latin typeface="Arial"/>
               </a:rPr>
-              <a:t>PMs decide collaboratively or defer to the correct PM; unresolved calls escalate to the Core Product Lead — decision within 3 business days (1 week if quarterly commitments are affected).</a:t>
+              <a:t>PMs decide collaboratively or defer to the correct PM; unresolved calls escalate to the Core Product Lead, decision within 3 business days (1 week if quarterly commitments are affected).</a:t>
             </a:r>
           </a:p>
           <a:p>
@@ -5852,7 +5852,7 @@
                 </a:solidFill>
                 <a:latin typeface="Arial"/>
               </a:rPr>
-              <a:t>anything touching wellness memory, user data, or personalization rules — all three PMs, with Privacy and Legal. Safety, legal, and regulatory requirements are non-negotiable.</a:t>
+              <a:t>anything touching wellness memory, user data, or personalization rules, all three PMs, with Privacy and Legal. Safety, legal, and regulatory requirements are non-negotiable.</a:t>
             </a:r>
           </a:p>
         </p:txBody>
@@ -6075,7 +6075,7 @@
                 </a:solidFill>
                 <a:latin typeface="Arial"/>
               </a:rPr>
-              <a:t>Generic wellness advice is free from every competitor. The alternatives don't fix the leak — acquisition pours users into the same bucket at $54 a head, and human coaching personalizes but can't scale. Rock #2 (personalized support using wellness memory) raises the value of users we already paid to acquire.</a:t>
+              <a:t>Generic wellness advice is free from every competitor. The alternatives don't fix the leak, acquisition pours users into the same bucket at $54 a head, and human coaching personalizes but can't scale. Rock #2 (personalized support using wellness memory) raises the value of users we already paid to acquire.</a:t>
             </a:r>
           </a:p>
         </p:txBody>
@@ -6253,7 +6253,7 @@
                           </a:solidFill>
                           <a:latin typeface="Arial"/>
                         </a:rPr>
-                        <a:t>$54 — unchanged</a:t>
+                        <a:t>$54, unchanged</a:t>
                       </a:r>
                     </a:p>
                   </a:txBody>
@@ -6297,7 +6297,7 @@
                           </a:solidFill>
                           <a:latin typeface="Arial"/>
                         </a:rPr>
-                        <a:t>$210K — one quarter of the pod</a:t>
+                        <a:t>$210K, one quarter of the pod</a:t>
                       </a:r>
                     </a:p>
                   </a:txBody>
@@ -6499,7 +6499,7 @@
                 </a:solidFill>
                 <a:latin typeface="Arial"/>
               </a:rPr>
-              <a:t>KILL CRITERIA — WRITTEN BEFORE LAUNCH, NOT NEGOTIATED AFTER</a:t>
+              <a:t>KILL CRITERIA, WRITTEN BEFORE LAUNCH, NOT NEGOTIATED AFTER</a:t>
             </a:r>
           </a:p>
         </p:txBody>
@@ -6932,7 +6932,7 @@
                 </a:solidFill>
                 <a:latin typeface="Arial"/>
               </a:rPr>
-              <a:t>The hardest part wasn't the strategy — it was turning “we collaborate” into decision rules that survive a real disagreement.</a:t>
+              <a:t>The hardest part wasn't the strategy, it was turning “we collaborate” into decision rules that survive a real disagreement.</a:t>
             </a:r>
           </a:p>
           <a:p>
@@ -6996,7 +6996,7 @@
                 </a:solidFill>
                 <a:latin typeface="Arial"/>
               </a:rPr>
-              <a:t>The AI pressure test caught my KR3 measuring an output in disguise — it is now an outcome: successful re-engagement.</a:t>
+              <a:t>The AI pressure test caught my KR3 measuring an output in disguise, it is now an outcome: successful re-engagement.</a:t>
             </a:r>
           </a:p>
         </p:txBody>
@@ -7310,7 +7310,7 @@
                 </a:solidFill>
                 <a:latin typeface="Arial"/>
               </a:rPr>
-              <a:t>Churn is a success problem, not a failure problem. Users don't leave Fable because it failed — they leave because it worked. The acute need ends, and so does the relationship. That one realization reorganized the entire strategy around the moment after success.</a:t>
+              <a:t>Churn is a success problem, not a failure problem. Users don't leave Fable because it failed, they leave because it worked. The acute need ends, and so does the relationship. That one realization reorganized the entire strategy around the moment after success.</a:t>
             </a:r>
           </a:p>
         </p:txBody>

</xml_diff>

<commit_message>
Normalize typography in final presentation deck
</commit_message>
<xml_diff>
--- a/05-insights/Fable-Final-Presentation.pptx
+++ b/05-insights/Fable-Final-Presentation.pptx
@@ -4102,7 +4102,7 @@
                 </a:solidFill>
                 <a:latin typeface="Arial"/>
               </a:rPr>
-              <a:t>42% → 65%   ·   </a:t>
+              <a:t>42% to 65%   ·   </a:t>
             </a:r>
           </a:p>
           <a:p>
@@ -4127,7 +4127,7 @@
                 </a:solidFill>
                 <a:latin typeface="Arial"/>
               </a:rPr>
-              <a:t>25% → 50%   ·   </a:t>
+              <a:t>25% to 50%   ·   </a:t>
             </a:r>
           </a:p>
           <a:p>
@@ -4152,7 +4152,7 @@
                 </a:solidFill>
                 <a:latin typeface="Arial"/>
               </a:rPr>
-              <a:t>30% → 55%</a:t>
+              <a:t>30% to 55%</a:t>
             </a:r>
           </a:p>
         </p:txBody>
@@ -4423,7 +4423,7 @@
                 </a:solidFill>
                 <a:latin typeface="Arial"/>
               </a:rPr>
-              <a:t>NOW · 0–3 MO</a:t>
+              <a:t>NOW · 0-3 MO</a:t>
             </a:r>
           </a:p>
         </p:txBody>
@@ -4471,7 +4471,7 @@
                 </a:solidFill>
                 <a:latin typeface="Arial"/>
               </a:rPr>
-              <a:t>, re-engagement, KR3 30% → 55% (PM2)</a:t>
+              <a:t>, re-engagement, KR3 30% to 55% (PM2)</a:t>
             </a:r>
           </a:p>
           <a:p>
@@ -4608,7 +4608,7 @@
                 </a:solidFill>
                 <a:latin typeface="Arial"/>
               </a:rPr>
-              <a:t>NEXT · 3–6 MO</a:t>
+              <a:t>NEXT · 3-6 MO</a:t>
             </a:r>
           </a:p>
         </p:txBody>
@@ -4647,7 +4647,7 @@
                 </a:solidFill>
                 <a:latin typeface="Arial"/>
               </a:rPr>
-              <a:t>•  Smoother acute → resilience transition</a:t>
+              <a:t>•  Smoother acute, resilience transition</a:t>
             </a:r>
             <a:r>
               <a:rPr sz="1200">
@@ -4793,7 +4793,7 @@
                 </a:solidFill>
                 <a:latin typeface="Arial"/>
               </a:rPr>
-              <a:t>LATER · 6–12 MO</a:t>
+              <a:t>LATER · 6-12 MO</a:t>
             </a:r>
           </a:p>
         </p:txBody>
@@ -5026,7 +5026,7 @@
                 </a:solidFill>
                 <a:latin typeface="Arial"/>
               </a:rPr>
-              <a:t>fix notifications (Rock #1) → AI check-in prompts personalized to user history (Rock #2, the big bet) → onboarding redesign on the 40% drop-off data (Rock #3).</a:t>
+              <a:t>fix notifications (Rock #1), AI check-in prompts personalized to user history (Rock #2, the big bet), onboarding redesign on the 40% drop-off data (Rock #3).</a:t>
             </a:r>
           </a:p>
           <a:p>
@@ -5409,7 +5409,7 @@
                 </a:solidFill>
                 <a:latin typeface="Arial"/>
               </a:rPr>
-              <a:t>, roadmap and OKRs for KR1–KR3</a:t>
+              <a:t>, roadmap and OKRs for KR1-KR3</a:t>
             </a:r>
           </a:p>
           <a:p>
@@ -6275,7 +6275,7 @@
                           </a:solidFill>
                           <a:latin typeface="Arial"/>
                         </a:rPr>
-                        <a:t>$118 → $171 (+45%)</a:t>
+                        <a:t>$118 to $171 (+45%)</a:t>
                       </a:r>
                     </a:p>
                   </a:txBody>
@@ -6538,7 +6538,7 @@
                 </a:solidFill>
                 <a:latin typeface="Arial"/>
               </a:rPr>
-              <a:t>•  KR1 below 52% by June 30, 2027 → </a:t>
+              <a:t>•  KR1 below 52% by June 30, 2027: </a:t>
             </a:r>
             <a:r>
               <a:rPr sz="1250">
@@ -6563,7 +6563,7 @@
                 </a:solidFill>
                 <a:latin typeface="Arial"/>
               </a:rPr>
-              <a:t>•  KR2 below 35% by June 30, 2027 → </a:t>
+              <a:t>•  KR2 below 35% by June 30, 2027: </a:t>
             </a:r>
             <a:r>
               <a:rPr sz="1250">
@@ -6588,7 +6588,7 @@
                 </a:solidFill>
                 <a:latin typeface="Arial"/>
               </a:rPr>
-              <a:t>•  KR3 up fewer than 5 points by September 30, 2027 → </a:t>
+              <a:t>•  KR3 up fewer than 5 points by September 30, 2027: </a:t>
             </a:r>
             <a:r>
               <a:rPr sz="1250">
@@ -6932,7 +6932,7 @@
                 </a:solidFill>
                 <a:latin typeface="Arial"/>
               </a:rPr>
-              <a:t>The hardest part wasn't the strategy, it was turning “we collaborate” into decision rules that survive a real disagreement.</a:t>
+              <a:t>The hardest part wasn't the strategy, it was turning "we collaborate" into decision rules that survive a real disagreement.</a:t>
             </a:r>
           </a:p>
           <a:p>

</xml_diff>